<commit_message>
.\Python\Lesson 07 - Data Structures"
</commit_message>
<xml_diff>
--- a/DevOps/Lesson 02 - Git Branching/Git Branching.pptx
+++ b/DevOps/Lesson 02 - Git Branching/Git Branching.pptx
@@ -218,7 +218,7 @@
           <a:p>
             <a:fld id="{7AE2CED0-0053-4CA5-BBA9-1B4221C85B40}" type="datetimeFigureOut">
               <a:rPr lang="en-US" smtClean="0"/>
-              <a:t>7/24/2026</a:t>
+              <a:t>7/27/2026</a:t>
             </a:fld>
             <a:endParaRPr lang="en-US"/>
           </a:p>
@@ -851,7 +851,7 @@
           <a:p>
             <a:fld id="{7A3E0868-4E26-4CDC-8A56-D70E2D8B12FE}" type="datetime3">
               <a:rPr lang="en-US" smtClean="0"/>
-              <a:t>24 July 2026</a:t>
+              <a:t>27 July 2026</a:t>
             </a:fld>
             <a:endParaRPr lang="en-US"/>
           </a:p>
@@ -3412,7 +3412,7 @@
           <a:p>
             <a:fld id="{A7B8021B-6105-4216-96FC-94348F216D0E}" type="datetime3">
               <a:rPr lang="en-US" smtClean="0"/>
-              <a:t>24 July 2026</a:t>
+              <a:t>27 July 2026</a:t>
             </a:fld>
             <a:endParaRPr lang="en-US"/>
           </a:p>
@@ -5109,7 +5109,7 @@
           <a:p>
             <a:fld id="{5D27CFAB-73E6-44A8-B862-B3306344E3F2}" type="datetime3">
               <a:rPr lang="en-US" smtClean="0"/>
-              <a:t>24 July 2026</a:t>
+              <a:t>27 July 2026</a:t>
             </a:fld>
             <a:endParaRPr lang="en-US"/>
           </a:p>
@@ -6899,7 +6899,7 @@
           <a:p>
             <a:fld id="{A9B2E784-A5F5-4301-881B-94AC8DBF9DED}" type="datetime3">
               <a:rPr lang="en-US" smtClean="0"/>
-              <a:t>24 July 2026</a:t>
+              <a:t>27 July 2026</a:t>
             </a:fld>
             <a:endParaRPr lang="en-US"/>
           </a:p>
@@ -7078,7 +7078,7 @@
           <a:p>
             <a:fld id="{18EAB3A5-9E92-4BB9-8F22-9632B4FBEDBA}" type="datetime3">
               <a:rPr lang="en-US" smtClean="0"/>
-              <a:t>24 July 2026</a:t>
+              <a:t>27 July 2026</a:t>
             </a:fld>
             <a:endParaRPr lang="en-US"/>
           </a:p>
@@ -7305,7 +7305,7 @@
           <a:p>
             <a:fld id="{40923810-5FB2-48C9-96CA-1DE2C4773142}" type="datetime3">
               <a:rPr lang="en-US" smtClean="0"/>
-              <a:t>24 July 2026</a:t>
+              <a:t>27 July 2026</a:t>
             </a:fld>
             <a:endParaRPr lang="en-US"/>
           </a:p>
@@ -7595,7 +7595,7 @@
           <a:p>
             <a:fld id="{E50EFF4B-86EB-42FB-93EA-7D8F9CB2466F}" type="datetime3">
               <a:rPr lang="en-US" smtClean="0"/>
-              <a:t>24 July 2026</a:t>
+              <a:t>27 July 2026</a:t>
             </a:fld>
             <a:endParaRPr lang="en-US"/>
           </a:p>
@@ -8207,7 +8207,7 @@
           <a:p>
             <a:fld id="{FB14FC24-E041-45E9-9A72-E5755A86890F}" type="datetime3">
               <a:rPr lang="en-US" smtClean="0"/>
-              <a:t>24 July 2026</a:t>
+              <a:t>27 July 2026</a:t>
             </a:fld>
             <a:endParaRPr lang="en-US"/>
           </a:p>
@@ -9067,7 +9067,7 @@
           <a:p>
             <a:fld id="{98A19125-94A7-4474-858C-FD9C4ABE9DDA}" type="datetime3">
               <a:rPr lang="en-US" smtClean="0"/>
-              <a:t>24 July 2026</a:t>
+              <a:t>27 July 2026</a:t>
             </a:fld>
             <a:endParaRPr lang="en-US"/>
           </a:p>
@@ -10170,7 +10170,7 @@
           <a:p>
             <a:fld id="{3BA0343D-C8D8-43CE-BB79-50DEA219DB07}" type="datetime3">
               <a:rPr lang="en-US" smtClean="0"/>
-              <a:t>24 July 2026</a:t>
+              <a:t>27 July 2026</a:t>
             </a:fld>
             <a:endParaRPr lang="en-US"/>
           </a:p>
@@ -10459,7 +10459,7 @@
           <a:p>
             <a:fld id="{453BD212-0B9F-4987-965F-AC83B2FC354F}" type="datetime3">
               <a:rPr lang="en-US" smtClean="0"/>
-              <a:t>24 July 2026</a:t>
+              <a:t>27 July 2026</a:t>
             </a:fld>
             <a:endParaRPr lang="en-US"/>
           </a:p>
@@ -10704,7 +10704,7 @@
           <a:p>
             <a:fld id="{6DDC931E-8CBE-4A3F-A034-9B6122C6DCDB}" type="datetime3">
               <a:rPr lang="en-US" smtClean="0"/>
-              <a:t>24 July 2026</a:t>
+              <a:t>27 July 2026</a:t>
             </a:fld>
             <a:endParaRPr lang="en-US"/>
           </a:p>
@@ -12470,7 +12470,7 @@
           <a:p>
             <a:fld id="{220AF9C2-5E8A-4308-AE6B-CA9B65007D0E}" type="datetime3">
               <a:rPr lang="en-US" smtClean="0"/>
-              <a:t>24 July 2026</a:t>
+              <a:t>27 July 2026</a:t>
             </a:fld>
             <a:endParaRPr lang="en-US"/>
           </a:p>
@@ -12783,7 +12783,7 @@
           <a:p>
             <a:fld id="{FF31E861-D2AF-431D-860B-DCF67C218052}" type="datetime3">
               <a:rPr lang="en-US" smtClean="0"/>
-              <a:t>24 July 2026</a:t>
+              <a:t>27 July 2026</a:t>
             </a:fld>
             <a:endParaRPr lang="en-US"/>
           </a:p>
@@ -13062,7 +13062,7 @@
           <a:p>
             <a:fld id="{D1DA25B2-AAF1-4C1F-AA38-12D5BFA7D4C8}" type="datetime3">
               <a:rPr lang="en-US" smtClean="0"/>
-              <a:t>24 July 2026</a:t>
+              <a:t>27 July 2026</a:t>
             </a:fld>
             <a:endParaRPr lang="en-US"/>
           </a:p>
@@ -13341,7 +13341,7 @@
           <a:p>
             <a:fld id="{A25C0F39-45D0-48E9-90B3-7FE8FCE561C8}" type="datetime3">
               <a:rPr lang="en-US" smtClean="0"/>
-              <a:t>24 July 2026</a:t>
+              <a:t>27 July 2026</a:t>
             </a:fld>
             <a:endParaRPr lang="en-US"/>
           </a:p>
@@ -13842,7 +13842,7 @@
           <a:p>
             <a:fld id="{9BAF1A3D-92FA-4F24-9781-74AFA516A230}" type="datetime3">
               <a:rPr lang="en-US" smtClean="0"/>
-              <a:t>24 July 2026</a:t>
+              <a:t>27 July 2026</a:t>
             </a:fld>
             <a:endParaRPr lang="en-US"/>
           </a:p>
@@ -13969,7 +13969,7 @@
           <a:p>
             <a:fld id="{5719C672-856D-4617-A693-8FE15749A9B7}" type="datetime3">
               <a:rPr lang="en-US" smtClean="0"/>
-              <a:t>24 July 2026</a:t>
+              <a:t>27 July 2026</a:t>
             </a:fld>
             <a:endParaRPr lang="en-US"/>
           </a:p>
@@ -14104,7 +14104,7 @@
           <a:p>
             <a:fld id="{5F6C764D-A39E-4C03-B161-E0BC66E8883B}" type="datetime3">
               <a:rPr lang="en-US" smtClean="0"/>
-              <a:t>24 July 2026</a:t>
+              <a:t>27 July 2026</a:t>
             </a:fld>
             <a:endParaRPr lang="en-US"/>
           </a:p>
@@ -14346,7 +14346,7 @@
           <a:p>
             <a:fld id="{6E3E33F9-20B7-4995-BE7D-165DBB597850}" type="datetime3">
               <a:rPr lang="en-US" smtClean="0"/>
-              <a:t>24 July 2026</a:t>
+              <a:t>27 July 2026</a:t>
             </a:fld>
             <a:endParaRPr lang="en-US"/>
           </a:p>
@@ -14459,7 +14459,7 @@
           <a:p>
             <a:fld id="{CD41C263-3501-4369-A962-62B6BF915CDE}" type="datetime3">
               <a:rPr lang="en-US" smtClean="0"/>
-              <a:t>24 July 2026</a:t>
+              <a:t>27 July 2026</a:t>
             </a:fld>
             <a:endParaRPr lang="en-US"/>
           </a:p>
@@ -14862,7 +14862,7 @@
           <a:p>
             <a:fld id="{B06F3EBE-B2E8-4992-9F00-9E4B44F057C0}" type="datetime3">
               <a:rPr lang="en-US" smtClean="0"/>
-              <a:t>24 July 2026</a:t>
+              <a:t>27 July 2026</a:t>
             </a:fld>
             <a:endParaRPr lang="en-US"/>
           </a:p>
@@ -14994,7 +14994,7 @@
           <a:p>
             <a:fld id="{D41656AB-D2E1-472E-8B95-0DF5C6E1D623}" type="datetime3">
               <a:rPr lang="en-US" smtClean="0"/>
-              <a:t>24 July 2026</a:t>
+              <a:t>27 July 2026</a:t>
             </a:fld>
             <a:endParaRPr lang="en-US"/>
           </a:p>
@@ -19226,7 +19226,7 @@
           <a:p>
             <a:fld id="{0BCBADB4-C04F-4E32-9A86-DF1B5AA91BC6}" type="datetimeFigureOut">
               <a:rPr lang="en-US" smtClean="0"/>
-              <a:t>7/24/2026</a:t>
+              <a:t>7/27/2026</a:t>
             </a:fld>
             <a:endParaRPr lang="en-US"/>
           </a:p>
@@ -19491,7 +19491,7 @@
           <a:p>
             <a:fld id="{0BCBADB4-C04F-4E32-9A86-DF1B5AA91BC6}" type="datetimeFigureOut">
               <a:rPr lang="en-US" smtClean="0"/>
-              <a:t>7/24/2026</a:t>
+              <a:t>7/27/2026</a:t>
             </a:fld>
             <a:endParaRPr lang="en-US"/>
           </a:p>
@@ -19687,7 +19687,7 @@
           <a:p>
             <a:fld id="{AD622D1A-DF83-41A8-85FF-04D90BF831D3}" type="datetime3">
               <a:rPr lang="en-US" smtClean="0"/>
-              <a:t>24 July 2026</a:t>
+              <a:t>27 July 2026</a:t>
             </a:fld>
             <a:endParaRPr lang="en-US"/>
           </a:p>
@@ -19937,7 +19937,7 @@
           <a:p>
             <a:fld id="{334F72C3-CDF3-44A8-B602-1649B1728485}" type="datetime3">
               <a:rPr lang="en-US" smtClean="0"/>
-              <a:t>24 July 2026</a:t>
+              <a:t>27 July 2026</a:t>
             </a:fld>
             <a:endParaRPr lang="en-US"/>
           </a:p>
@@ -20244,7 +20244,7 @@
           <a:p>
             <a:fld id="{1E0132BA-B5E7-4FFD-AF6C-169169D47D4A}" type="datetime3">
               <a:rPr lang="en-US" smtClean="0"/>
-              <a:t>24 July 2026</a:t>
+              <a:t>27 July 2026</a:t>
             </a:fld>
             <a:endParaRPr lang="en-US"/>
           </a:p>
@@ -20725,7 +20725,7 @@
           <a:p>
             <a:fld id="{81A30091-1C2A-4151-8D3C-D1E47A72615F}" type="datetime3">
               <a:rPr lang="en-US" smtClean="0"/>
-              <a:t>24 July 2026</a:t>
+              <a:t>27 July 2026</a:t>
             </a:fld>
             <a:endParaRPr lang="en-US"/>
           </a:p>
@@ -21362,7 +21362,7 @@
           <a:p>
             <a:fld id="{35D703CE-07B4-4C05-A488-B4566700621F}" type="datetime3">
               <a:rPr lang="en-US" smtClean="0"/>
-              <a:t>24 July 2026</a:t>
+              <a:t>27 July 2026</a:t>
             </a:fld>
             <a:endParaRPr lang="en-US"/>
           </a:p>
@@ -22420,7 +22420,7 @@
           <a:p>
             <a:fld id="{694BD61C-20BA-43AF-A21F-1DAFB3200099}" type="datetime3">
               <a:rPr lang="en-US" smtClean="0"/>
-              <a:t>24 July 2026</a:t>
+              <a:t>27 July 2026</a:t>
             </a:fld>
             <a:endParaRPr lang="en-US"/>
           </a:p>
@@ -22907,7 +22907,7 @@
           <a:p>
             <a:fld id="{CABCB1B0-B6E5-4DD1-BB55-95C076D6C0C8}" type="datetime3">
               <a:rPr lang="en-US" smtClean="0"/>
-              <a:t>24 July 2026</a:t>
+              <a:t>27 July 2026</a:t>
             </a:fld>
             <a:endParaRPr lang="en-US"/>
           </a:p>
@@ -23704,7 +23704,7 @@
           <a:p>
             <a:r>
               <a:rPr lang="en-US" dirty="0"/>
-              <a:t>Git Branching</a:t>
+              <a:t>Branching</a:t>
             </a:r>
           </a:p>
         </p:txBody>
@@ -24879,7 +24879,7 @@
           <p:nvPr>
             <p:extLst>
               <p:ext uri="{D42A27DB-BD31-4B8C-83A1-F6EECF244321}">
-                <p14:modId xmlns:p14="http://schemas.microsoft.com/office/powerpoint/2010/main" val="3440821790"/>
+                <p14:modId xmlns:p14="http://schemas.microsoft.com/office/powerpoint/2010/main" val="1070067784"/>
               </p:ext>
             </p:extLst>
           </p:nvPr>
@@ -25293,7 +25293,7 @@
                       <a:headEnd type="none" w="sm" len="sm"/>
                       <a:tailEnd type="none" w="sm" len="sm"/>
                     </a:lnR>
-                    <a:lnT w="9525" cap="flat" cmpd="sng" algn="ctr">
+                    <a:lnT w="9525" cap="flat" cmpd="sng">
                       <a:solidFill>
                         <a:srgbClr val="000000">
                           <a:alpha val="0"/>
@@ -25366,7 +25366,7 @@
                       <a:headEnd type="none" w="sm" len="sm"/>
                       <a:tailEnd type="none" w="sm" len="sm"/>
                     </a:lnR>
-                    <a:lnT w="9525" cap="flat" cmpd="sng" algn="ctr">
+                    <a:lnT w="9525" cap="flat" cmpd="sng">
                       <a:solidFill>
                         <a:srgbClr val="000000">
                           <a:alpha val="0"/>
@@ -25580,7 +25580,7 @@
                         <a:defRPr/>
                       </a:pPr>
                       <a:r>
-                        <a:rPr lang="en-US" sz="1800" u="none" strike="noStrike" cap="none" dirty="0">
+                        <a:rPr lang="en-US" sz="1600" u="none" strike="noStrike" cap="none" dirty="0">
                           <a:latin typeface="Courier New"/>
                           <a:ea typeface="Courier New"/>
                           <a:cs typeface="Courier New"/>
@@ -25588,7 +25588,7 @@
                         </a:rPr>
                         <a:t>git merge --squash feature-a</a:t>
                       </a:r>
-                      <a:endParaRPr lang="en-US" sz="1800" dirty="0"/>
+                      <a:endParaRPr lang="en-US" dirty="0"/>
                     </a:p>
                   </a:txBody>
                   <a:tcPr marL="91450" marR="91450" marT="45725" marB="45725" anchor="ctr">
@@ -25897,7 +25897,7 @@
         </p:blipFill>
         <p:spPr bwMode="auto">
           <a:xfrm>
-            <a:off x="5607192" y="987425"/>
+            <a:off x="5607192" y="1005897"/>
             <a:ext cx="5324191" cy="4873625"/>
           </a:xfrm>
           <a:prstGeom prst="rect">
@@ -29291,7 +29291,7 @@
           <a:p>
             <a:fld id="{AD622D1A-DF83-41A8-85FF-04D90BF831D3}" type="datetime3">
               <a:rPr lang="en-US" smtClean="0"/>
-              <a:t>24 July 2026</a:t>
+              <a:t>27 July 2026</a:t>
             </a:fld>
             <a:endParaRPr lang="en-US"/>
           </a:p>

</xml_diff>